<commit_message>
Clarify cost assumption throughout; update README to reflect completed project
- README: full results table (AUC, n, expected impact), feature list,
  updated output schema, explicit note that c=2% is a stated assumption
  not a derived figure — sensitivity table is the primary output
- 04_outreach_sizing.ipynb: updated comments to flag c=2% as an
  assumption ('constant but unknown' per assignment spec)
- WellCo_Churn_Presentation.pptx: slide 5 now explicitly notes that
  4,369 assumes c=2% and WellCo should substitute their actual numbers

Co-Authored-By: Claude Sonnet 4.6 <noreply@anthropic.com>
</commit_message>
<xml_diff>
--- a/Shay_Assignment/WellCo_Churn_Presentation.pptx
+++ b/Shay_Assignment/WellCo_Churn_Presentation.pptx
@@ -5841,12 +5841,13 @@
           <a:p>
             <a:pPr algn="l"/>
             <a:r>
-              <a:rPr sz="1200" b="0">
+              <a:rPr sz="1100">
                 <a:solidFill>
                   <a:srgbClr val="556577"/>
                 </a:solidFill>
               </a:rPr>
-              <a:t>Every outreach has a cost. We only recommend contacting someone when the expected benefit of keeping them — preventing a churn — is worth more than the cost of the call or message. At 4,369 members, every contact pays for itself. Beyond that, the benefit drops below the cost.</a:t>
+              <a:t>Every outreach has a cost. We only recommend contacting someone when the expected benefit of keeping them exceeds the cost of the outreach. At 4,369 members, every contact pays for itself — beyond that, the benefit drops below the cost.
+⚠ Note: the exact n depends on your cost-per-outreach and retention value. 4,369 assumes cost ≈ 2% of retention value — a reasonable baseline for digital outreach, but WellCo should substitute their actual numbers.</a:t>
             </a:r>
           </a:p>
         </p:txBody>

</xml_diff>